<commit_message>
Presentations: keep the cartilhas' own exercise photos
The decks were built with the new design-system illustrations, which are not in
the cartilhas yet - so the patient would see one thing on the shared screen and
another when she opened the app afterwards. Both decks now use the photographs
that are actually in the cartilhas.

The exercise card also follows the picture's proportions now: the photos are
portrait and the fixed box left a wide white band beside them.

USAR_ILUSTRACOES_NOVAS stays in both generators, switched off, for the day the
new illustrations do land in the cartilhas.

Co-Authored-By: Claude Opus 4.8 <noreply@anthropic.com>
</commit_message>
<xml_diff>
--- a/design/apresentacoes/Cartilha-Halux-Valgo-Apresentacao.pptx
+++ b/design/apresentacoes/Cartilha-Halux-Valgo-Apresentacao.pptx
@@ -14029,8 +14029,8 @@
         </p:nvSpPr>
         <p:spPr>
           <a:xfrm>
-            <a:off x="566928" y="1920240"/>
-            <a:ext cx="5989320" cy="4123944"/>
+            <a:off x="566928" y="2181987"/>
+            <a:ext cx="5989320" cy="3600450"/>
           </a:xfrm>
           <a:prstGeom prst="roundRect">
             <a:avLst>
@@ -14069,7 +14069,7 @@
       </p:sp>
       <p:pic>
         <p:nvPicPr>
-          <p:cNvPr id="9" name="Picture 8" descr="01_ball_release-static_webp.jpg"/>
+          <p:cNvPr id="9" name="Picture 8" descr="01_ball_release_jpg.jpg"/>
           <p:cNvPicPr>
             <a:picLocks noChangeAspect="1"/>
           </p:cNvPicPr>
@@ -14083,8 +14083,8 @@
         </p:blipFill>
         <p:spPr>
           <a:xfrm>
-            <a:off x="676656" y="2074951"/>
-            <a:ext cx="5769864" cy="3814521"/>
+            <a:off x="694944" y="2310003"/>
+            <a:ext cx="5733288" cy="3344418"/>
           </a:xfrm>
           <a:prstGeom prst="rect">
             <a:avLst/>
@@ -14927,8 +14927,8 @@
         </p:nvSpPr>
         <p:spPr>
           <a:xfrm>
-            <a:off x="566928" y="1920240"/>
-            <a:ext cx="5989320" cy="4123944"/>
+            <a:off x="862048" y="1920240"/>
+            <a:ext cx="5399079" cy="4123944"/>
           </a:xfrm>
           <a:prstGeom prst="roundRect">
             <a:avLst>
@@ -14967,7 +14967,7 @@
       </p:sp>
       <p:pic>
         <p:nvPicPr>
-          <p:cNvPr id="9" name="Picture 8" descr="02_passive_movements-static_webp.jpg"/>
+          <p:cNvPr id="9" name="Picture 8" descr="02_passive_movements_jpg.jpg"/>
           <p:cNvPicPr>
             <a:picLocks noChangeAspect="1"/>
           </p:cNvPicPr>
@@ -14981,8 +14981,8 @@
         </p:blipFill>
         <p:spPr>
           <a:xfrm>
-            <a:off x="676656" y="2074951"/>
-            <a:ext cx="5769864" cy="3814521"/>
+            <a:off x="990064" y="2048256"/>
+            <a:ext cx="5143047" cy="3867911"/>
           </a:xfrm>
           <a:prstGeom prst="rect">
             <a:avLst/>
@@ -15548,8 +15548,8 @@
         </p:nvSpPr>
         <p:spPr>
           <a:xfrm>
-            <a:off x="566928" y="1920240"/>
-            <a:ext cx="5989320" cy="4123944"/>
+            <a:off x="566928" y="1996934"/>
+            <a:ext cx="5989320" cy="3970556"/>
           </a:xfrm>
           <a:prstGeom prst="roundRect">
             <a:avLst>
@@ -15588,7 +15588,7 @@
       </p:sp>
       <p:pic>
         <p:nvPicPr>
-          <p:cNvPr id="9" name="Picture 8" descr="03_joint_traction-static_webp.jpg"/>
+          <p:cNvPr id="9" name="Picture 8" descr="03_joint_traction_jpg.jpg"/>
           <p:cNvPicPr>
             <a:picLocks noChangeAspect="1"/>
           </p:cNvPicPr>
@@ -15602,8 +15602,8 @@
         </p:blipFill>
         <p:spPr>
           <a:xfrm>
-            <a:off x="676656" y="2074951"/>
-            <a:ext cx="5769864" cy="3814521"/>
+            <a:off x="694944" y="2124950"/>
+            <a:ext cx="5733287" cy="3714524"/>
           </a:xfrm>
           <a:prstGeom prst="rect">
             <a:avLst/>
@@ -16169,8 +16169,8 @@
         </p:nvSpPr>
         <p:spPr>
           <a:xfrm>
-            <a:off x="566928" y="1920240"/>
-            <a:ext cx="5989320" cy="4123944"/>
+            <a:off x="566928" y="2020505"/>
+            <a:ext cx="5989320" cy="3923414"/>
           </a:xfrm>
           <a:prstGeom prst="roundRect">
             <a:avLst>
@@ -16209,7 +16209,7 @@
       </p:sp>
       <p:pic>
         <p:nvPicPr>
-          <p:cNvPr id="9" name="Picture 8" descr="04_joint_mobilization-static_webp.jpg"/>
+          <p:cNvPr id="9" name="Picture 8" descr="04_joint_mobilization_jpg.jpg"/>
           <p:cNvPicPr>
             <a:picLocks noChangeAspect="1"/>
           </p:cNvPicPr>
@@ -16223,8 +16223,8 @@
         </p:blipFill>
         <p:spPr>
           <a:xfrm>
-            <a:off x="676656" y="2074951"/>
-            <a:ext cx="5769864" cy="3814521"/>
+            <a:off x="694944" y="2148521"/>
+            <a:ext cx="5733287" cy="3667382"/>
           </a:xfrm>
           <a:prstGeom prst="rect">
             <a:avLst/>
@@ -16790,8 +16790,8 @@
         </p:nvSpPr>
         <p:spPr>
           <a:xfrm>
-            <a:off x="566928" y="1920240"/>
-            <a:ext cx="5989320" cy="4123944"/>
+            <a:off x="566928" y="1977847"/>
+            <a:ext cx="5989320" cy="4008729"/>
           </a:xfrm>
           <a:prstGeom prst="roundRect">
             <a:avLst>
@@ -16830,7 +16830,7 @@
       </p:sp>
       <p:pic>
         <p:nvPicPr>
-          <p:cNvPr id="9" name="Picture 8" descr="05_extensor_release-static_webp.jpg"/>
+          <p:cNvPr id="9" name="Picture 8" descr="05_extensor_release_jpg.jpg"/>
           <p:cNvPicPr>
             <a:picLocks noChangeAspect="1"/>
           </p:cNvPicPr>
@@ -16844,8 +16844,8 @@
         </p:blipFill>
         <p:spPr>
           <a:xfrm>
-            <a:off x="676656" y="2074951"/>
-            <a:ext cx="5769864" cy="3814521"/>
+            <a:off x="694944" y="2105863"/>
+            <a:ext cx="5733287" cy="3752697"/>
           </a:xfrm>
           <a:prstGeom prst="rect">
             <a:avLst/>
@@ -17411,8 +17411,8 @@
         </p:nvSpPr>
         <p:spPr>
           <a:xfrm>
-            <a:off x="566928" y="1920240"/>
-            <a:ext cx="5989320" cy="4123944"/>
+            <a:off x="566928" y="1961889"/>
+            <a:ext cx="5989320" cy="4040646"/>
           </a:xfrm>
           <a:prstGeom prst="roundRect">
             <a:avLst>
@@ -17451,7 +17451,7 @@
       </p:sp>
       <p:pic>
         <p:nvPicPr>
-          <p:cNvPr id="9" name="Picture 8" descr="06_capsule_massage-static_webp.jpg"/>
+          <p:cNvPr id="9" name="Picture 8" descr="06_joint_line_capsule_massage_jpg.jpg"/>
           <p:cNvPicPr>
             <a:picLocks noChangeAspect="1"/>
           </p:cNvPicPr>
@@ -17465,8 +17465,8 @@
         </p:blipFill>
         <p:spPr>
           <a:xfrm>
-            <a:off x="676656" y="2074951"/>
-            <a:ext cx="5769864" cy="3814521"/>
+            <a:off x="694944" y="2089905"/>
+            <a:ext cx="5733287" cy="3784614"/>
           </a:xfrm>
           <a:prstGeom prst="rect">
             <a:avLst/>
@@ -18555,8 +18555,8 @@
         </p:nvSpPr>
         <p:spPr>
           <a:xfrm>
-            <a:off x="566928" y="1920240"/>
-            <a:ext cx="5989320" cy="4123944"/>
+            <a:off x="963245" y="1920240"/>
+            <a:ext cx="5196685" cy="4123944"/>
           </a:xfrm>
           <a:prstGeom prst="roundRect">
             <a:avLst>
@@ -18595,7 +18595,7 @@
       </p:sp>
       <p:pic>
         <p:nvPicPr>
-          <p:cNvPr id="9" name="Picture 8" descr="07_flexion_stretch-static_webp.jpg"/>
+          <p:cNvPr id="9" name="Picture 8" descr="07_big_toe_flexion_stretch_jpg.jpg"/>
           <p:cNvPicPr>
             <a:picLocks noChangeAspect="1"/>
           </p:cNvPicPr>
@@ -18609,8 +18609,8 @@
         </p:blipFill>
         <p:spPr>
           <a:xfrm>
-            <a:off x="676656" y="2074951"/>
-            <a:ext cx="5769864" cy="3814521"/>
+            <a:off x="1091261" y="2048256"/>
+            <a:ext cx="4940653" cy="3867911"/>
           </a:xfrm>
           <a:prstGeom prst="rect">
             <a:avLst/>
@@ -19176,8 +19176,8 @@
         </p:nvSpPr>
         <p:spPr>
           <a:xfrm>
-            <a:off x="566928" y="1920240"/>
-            <a:ext cx="5989320" cy="4123944"/>
+            <a:off x="1342809" y="1920240"/>
+            <a:ext cx="4437558" cy="4123944"/>
           </a:xfrm>
           <a:prstGeom prst="roundRect">
             <a:avLst>
@@ -19216,7 +19216,7 @@
       </p:sp>
       <p:pic>
         <p:nvPicPr>
-          <p:cNvPr id="9" name="Picture 8" descr="08_extension_stretch-static_webp.jpg"/>
+          <p:cNvPr id="9" name="Picture 8" descr="08_big_toe_extension_stretch_jpg.jpg"/>
           <p:cNvPicPr>
             <a:picLocks noChangeAspect="1"/>
           </p:cNvPicPr>
@@ -19230,8 +19230,8 @@
         </p:blipFill>
         <p:spPr>
           <a:xfrm>
-            <a:off x="676656" y="2074951"/>
-            <a:ext cx="5769864" cy="3814521"/>
+            <a:off x="1470825" y="2048256"/>
+            <a:ext cx="4181526" cy="3867911"/>
           </a:xfrm>
           <a:prstGeom prst="rect">
             <a:avLst/>
@@ -19797,8 +19797,8 @@
         </p:nvSpPr>
         <p:spPr>
           <a:xfrm>
-            <a:off x="566928" y="1920240"/>
-            <a:ext cx="5989320" cy="4123944"/>
+            <a:off x="1001085" y="1920240"/>
+            <a:ext cx="5121005" cy="4123944"/>
           </a:xfrm>
           <a:prstGeom prst="roundRect">
             <a:avLst>
@@ -19837,7 +19837,7 @@
       </p:sp>
       <p:pic>
         <p:nvPicPr>
-          <p:cNvPr id="9" name="Picture 8" descr="09_extension_wall-static_webp.jpg"/>
+          <p:cNvPr id="9" name="Picture 8" descr="09_big_toe_extension_against_wall_jpg.jpg"/>
           <p:cNvPicPr>
             <a:picLocks noChangeAspect="1"/>
           </p:cNvPicPr>
@@ -19851,8 +19851,8 @@
         </p:blipFill>
         <p:spPr>
           <a:xfrm>
-            <a:off x="676656" y="2074951"/>
-            <a:ext cx="5769864" cy="3814521"/>
+            <a:off x="1129101" y="2048256"/>
+            <a:ext cx="4864973" cy="3867911"/>
           </a:xfrm>
           <a:prstGeom prst="rect">
             <a:avLst/>
@@ -20418,8 +20418,8 @@
         </p:nvSpPr>
         <p:spPr>
           <a:xfrm>
-            <a:off x="566928" y="1920240"/>
-            <a:ext cx="5989320" cy="4123944"/>
+            <a:off x="860798" y="1920240"/>
+            <a:ext cx="5401580" cy="4123944"/>
           </a:xfrm>
           <a:prstGeom prst="roundRect">
             <a:avLst>
@@ -20458,7 +20458,7 @@
       </p:sp>
       <p:pic>
         <p:nvPicPr>
-          <p:cNvPr id="9" name="Picture 8" descr="10_advanced_extension-static_webp.jpg"/>
+          <p:cNvPr id="9" name="Picture 8" descr="10_advanced_extension_stretch_jpg.jpg"/>
           <p:cNvPicPr>
             <a:picLocks noChangeAspect="1"/>
           </p:cNvPicPr>
@@ -20472,8 +20472,8 @@
         </p:blipFill>
         <p:spPr>
           <a:xfrm>
-            <a:off x="676656" y="2074951"/>
-            <a:ext cx="5769864" cy="3814521"/>
+            <a:off x="988814" y="2048256"/>
+            <a:ext cx="5145548" cy="3867911"/>
           </a:xfrm>
           <a:prstGeom prst="rect">
             <a:avLst/>
@@ -21558,8 +21558,8 @@
         </p:nvSpPr>
         <p:spPr>
           <a:xfrm>
-            <a:off x="566928" y="1920240"/>
-            <a:ext cx="5989320" cy="4123944"/>
+            <a:off x="989052" y="1920240"/>
+            <a:ext cx="5145072" cy="4123944"/>
           </a:xfrm>
           <a:prstGeom prst="roundRect">
             <a:avLst>
@@ -21598,7 +21598,7 @@
       </p:sp>
       <p:pic>
         <p:nvPicPr>
-          <p:cNvPr id="9" name="Picture 8" descr="11_abduction_stretch-static_webp.jpg"/>
+          <p:cNvPr id="9" name="Picture 8" descr="11_big_toe_abduction_stretch_jpg.jpg"/>
           <p:cNvPicPr>
             <a:picLocks noChangeAspect="1"/>
           </p:cNvPicPr>
@@ -21612,8 +21612,8 @@
         </p:blipFill>
         <p:spPr>
           <a:xfrm>
-            <a:off x="676656" y="2074951"/>
-            <a:ext cx="5769864" cy="3814521"/>
+            <a:off x="1117068" y="2048256"/>
+            <a:ext cx="4889040" cy="3867911"/>
           </a:xfrm>
           <a:prstGeom prst="rect">
             <a:avLst/>
@@ -22674,8 +22674,8 @@
         </p:nvSpPr>
         <p:spPr>
           <a:xfrm>
-            <a:off x="566928" y="1920240"/>
-            <a:ext cx="5989320" cy="4123944"/>
+            <a:off x="2125514" y="1920240"/>
+            <a:ext cx="2872147" cy="4123944"/>
           </a:xfrm>
           <a:prstGeom prst="roundRect">
             <a:avLst>
@@ -22714,7 +22714,7 @@
       </p:sp>
       <p:pic>
         <p:nvPicPr>
-          <p:cNvPr id="9" name="Picture 8" descr="12_big_toe_lift-static_webp.jpg"/>
+          <p:cNvPr id="9" name="Picture 8" descr="12_big_toe_lift_jpg.jpg"/>
           <p:cNvPicPr>
             <a:picLocks noChangeAspect="1"/>
           </p:cNvPicPr>
@@ -22728,8 +22728,8 @@
         </p:blipFill>
         <p:spPr>
           <a:xfrm>
-            <a:off x="676656" y="2074951"/>
-            <a:ext cx="5769864" cy="3814521"/>
+            <a:off x="2253530" y="2048256"/>
+            <a:ext cx="2616115" cy="3867911"/>
           </a:xfrm>
           <a:prstGeom prst="rect">
             <a:avLst/>
@@ -23295,8 +23295,8 @@
         </p:nvSpPr>
         <p:spPr>
           <a:xfrm>
-            <a:off x="566928" y="1920240"/>
-            <a:ext cx="5989320" cy="4123944"/>
+            <a:off x="566928" y="2001478"/>
+            <a:ext cx="5989320" cy="3961468"/>
           </a:xfrm>
           <a:prstGeom prst="roundRect">
             <a:avLst>
@@ -23335,7 +23335,7 @@
       </p:sp>
       <p:pic>
         <p:nvPicPr>
-          <p:cNvPr id="9" name="Picture 8" descr="13_big_toe_press-static_webp.jpg"/>
+          <p:cNvPr id="9" name="Picture 8" descr="13_big_toe_press_down_jpg.jpg"/>
           <p:cNvPicPr>
             <a:picLocks noChangeAspect="1"/>
           </p:cNvPicPr>
@@ -23349,8 +23349,8 @@
         </p:blipFill>
         <p:spPr>
           <a:xfrm>
-            <a:off x="676656" y="2074951"/>
-            <a:ext cx="5769864" cy="3814521"/>
+            <a:off x="694945" y="2129494"/>
+            <a:ext cx="5733286" cy="3705436"/>
           </a:xfrm>
           <a:prstGeom prst="rect">
             <a:avLst/>
@@ -23916,8 +23916,8 @@
         </p:nvSpPr>
         <p:spPr>
           <a:xfrm>
-            <a:off x="566928" y="1920240"/>
-            <a:ext cx="5989320" cy="4123944"/>
+            <a:off x="1846939" y="1920240"/>
+            <a:ext cx="3429298" cy="4123944"/>
           </a:xfrm>
           <a:prstGeom prst="roundRect">
             <a:avLst>
@@ -23956,7 +23956,7 @@
       </p:sp>
       <p:pic>
         <p:nvPicPr>
-          <p:cNvPr id="9" name="Picture 8" descr="14_abduction_isometric-static_webp.jpg"/>
+          <p:cNvPr id="9" name="Picture 8" descr="14_abduction_isometric_jpg.jpg"/>
           <p:cNvPicPr>
             <a:picLocks noChangeAspect="1"/>
           </p:cNvPicPr>
@@ -23970,8 +23970,8 @@
         </p:blipFill>
         <p:spPr>
           <a:xfrm>
-            <a:off x="676656" y="2074951"/>
-            <a:ext cx="5769864" cy="3814521"/>
+            <a:off x="1974955" y="2048256"/>
+            <a:ext cx="3173266" cy="3867911"/>
           </a:xfrm>
           <a:prstGeom prst="rect">
             <a:avLst/>
@@ -24537,8 +24537,8 @@
         </p:nvSpPr>
         <p:spPr>
           <a:xfrm>
-            <a:off x="566928" y="1920240"/>
-            <a:ext cx="5989320" cy="4123944"/>
+            <a:off x="2150527" y="1920240"/>
+            <a:ext cx="2822122" cy="4123944"/>
           </a:xfrm>
           <a:prstGeom prst="roundRect">
             <a:avLst>
@@ -24577,7 +24577,7 @@
       </p:sp>
       <p:pic>
         <p:nvPicPr>
-          <p:cNvPr id="9" name="Picture 8" descr="15_spread_squeeze-static_webp.jpg"/>
+          <p:cNvPr id="9" name="Picture 8" descr="15_spread_squeeze_jpg.jpg"/>
           <p:cNvPicPr>
             <a:picLocks noChangeAspect="1"/>
           </p:cNvPicPr>
@@ -24591,8 +24591,8 @@
         </p:blipFill>
         <p:spPr>
           <a:xfrm>
-            <a:off x="676656" y="2074951"/>
-            <a:ext cx="5769864" cy="3814521"/>
+            <a:off x="2278543" y="2048256"/>
+            <a:ext cx="2566090" cy="3867911"/>
           </a:xfrm>
           <a:prstGeom prst="rect">
             <a:avLst/>
@@ -25625,8 +25625,8 @@
         </p:nvSpPr>
         <p:spPr>
           <a:xfrm>
-            <a:off x="566928" y="1920240"/>
-            <a:ext cx="5989320" cy="4123944"/>
+            <a:off x="2449282" y="1920240"/>
+            <a:ext cx="2224611" cy="4123944"/>
           </a:xfrm>
           <a:prstGeom prst="roundRect">
             <a:avLst>
@@ -25665,7 +25665,7 @@
       </p:sp>
       <p:pic>
         <p:nvPicPr>
-          <p:cNvPr id="9" name="Picture 8" descr="16_forward_lean-static_webp.jpg"/>
+          <p:cNvPr id="9" name="Picture 8" descr="16_forward_lean_jpg.jpg"/>
           <p:cNvPicPr>
             <a:picLocks noChangeAspect="1"/>
           </p:cNvPicPr>
@@ -25679,8 +25679,8 @@
         </p:blipFill>
         <p:spPr>
           <a:xfrm>
-            <a:off x="676656" y="2074951"/>
-            <a:ext cx="5769864" cy="3814521"/>
+            <a:off x="2577298" y="2048256"/>
+            <a:ext cx="1968579" cy="3867911"/>
           </a:xfrm>
           <a:prstGeom prst="rect">
             <a:avLst/>
@@ -26246,8 +26246,8 @@
         </p:nvSpPr>
         <p:spPr>
           <a:xfrm>
-            <a:off x="566928" y="1920240"/>
-            <a:ext cx="5989320" cy="4123944"/>
+            <a:off x="2036826" y="1920240"/>
+            <a:ext cx="3049524" cy="4123944"/>
           </a:xfrm>
           <a:prstGeom prst="roundRect">
             <a:avLst>
@@ -26286,7 +26286,7 @@
       </p:sp>
       <p:pic>
         <p:nvPicPr>
-          <p:cNvPr id="9" name="Picture 8" descr="17_heel_raise-static_webp.jpg"/>
+          <p:cNvPr id="9" name="Picture 8" descr="17_heel_raise_jpg.jpg"/>
           <p:cNvPicPr>
             <a:picLocks noChangeAspect="1"/>
           </p:cNvPicPr>
@@ -26300,8 +26300,8 @@
         </p:blipFill>
         <p:spPr>
           <a:xfrm>
-            <a:off x="676656" y="2074951"/>
-            <a:ext cx="5769864" cy="3814521"/>
+            <a:off x="2164842" y="2048256"/>
+            <a:ext cx="2793492" cy="3867912"/>
           </a:xfrm>
           <a:prstGeom prst="rect">
             <a:avLst/>
@@ -26867,8 +26867,8 @@
         </p:nvSpPr>
         <p:spPr>
           <a:xfrm>
-            <a:off x="566928" y="1920240"/>
-            <a:ext cx="5989320" cy="4123944"/>
+            <a:off x="2044580" y="1920240"/>
+            <a:ext cx="3034016" cy="4123944"/>
           </a:xfrm>
           <a:prstGeom prst="roundRect">
             <a:avLst>
@@ -26907,7 +26907,7 @@
       </p:sp>
       <p:pic>
         <p:nvPicPr>
-          <p:cNvPr id="9" name="Picture 8" descr="18_push_off-static_webp.jpg"/>
+          <p:cNvPr id="9" name="Picture 8" descr="18_push_off_with_trailing_leg_jpg.jpg"/>
           <p:cNvPicPr>
             <a:picLocks noChangeAspect="1"/>
           </p:cNvPicPr>
@@ -26921,8 +26921,8 @@
         </p:blipFill>
         <p:spPr>
           <a:xfrm>
-            <a:off x="676656" y="2074951"/>
-            <a:ext cx="5769864" cy="3814521"/>
+            <a:off x="2172596" y="2048257"/>
+            <a:ext cx="2777984" cy="3867910"/>
           </a:xfrm>
           <a:prstGeom prst="rect">
             <a:avLst/>
@@ -29158,8 +29158,8 @@
         </p:nvSpPr>
         <p:spPr>
           <a:xfrm>
-            <a:off x="566928" y="1920240"/>
-            <a:ext cx="5989320" cy="4123944"/>
+            <a:off x="1704305" y="1920240"/>
+            <a:ext cx="3714566" cy="4123944"/>
           </a:xfrm>
           <a:prstGeom prst="roundRect">
             <a:avLst>
@@ -29198,7 +29198,7 @@
       </p:sp>
       <p:pic>
         <p:nvPicPr>
-          <p:cNvPr id="9" name="Picture 8" descr="19_lunges-static_webp.jpg"/>
+          <p:cNvPr id="9" name="Picture 8" descr="19_lunges_jpg.jpg"/>
           <p:cNvPicPr>
             <a:picLocks noChangeAspect="1"/>
           </p:cNvPicPr>
@@ -29212,8 +29212,8 @@
         </p:blipFill>
         <p:spPr>
           <a:xfrm>
-            <a:off x="676656" y="2074951"/>
-            <a:ext cx="5769864" cy="3814521"/>
+            <a:off x="1832321" y="2048256"/>
+            <a:ext cx="3458534" cy="3867911"/>
           </a:xfrm>
           <a:prstGeom prst="rect">
             <a:avLst/>
@@ -29779,8 +29779,8 @@
         </p:nvSpPr>
         <p:spPr>
           <a:xfrm>
-            <a:off x="566928" y="1920240"/>
-            <a:ext cx="5989320" cy="4123944"/>
+            <a:off x="566928" y="2258431"/>
+            <a:ext cx="5989320" cy="3447562"/>
           </a:xfrm>
           <a:prstGeom prst="roundRect">
             <a:avLst>
@@ -29819,7 +29819,7 @@
       </p:sp>
       <p:pic>
         <p:nvPicPr>
-          <p:cNvPr id="9" name="Picture 8" descr="20_mountain_climbers-static_webp.jpg"/>
+          <p:cNvPr id="9" name="Picture 8" descr="20_mountain_climbers_jpg.jpg"/>
           <p:cNvPicPr>
             <a:picLocks noChangeAspect="1"/>
           </p:cNvPicPr>
@@ -29833,8 +29833,8 @@
         </p:blipFill>
         <p:spPr>
           <a:xfrm>
-            <a:off x="676656" y="2074951"/>
-            <a:ext cx="5769864" cy="3814521"/>
+            <a:off x="694944" y="2386447"/>
+            <a:ext cx="5733287" cy="3191530"/>
           </a:xfrm>
           <a:prstGeom prst="rect">
             <a:avLst/>
@@ -30400,8 +30400,8 @@
         </p:nvSpPr>
         <p:spPr>
           <a:xfrm>
-            <a:off x="566928" y="1920240"/>
-            <a:ext cx="5989320" cy="4123944"/>
+            <a:off x="1761147" y="1920240"/>
+            <a:ext cx="3600881" cy="4123944"/>
           </a:xfrm>
           <a:prstGeom prst="roundRect">
             <a:avLst>
@@ -30440,7 +30440,7 @@
       </p:sp>
       <p:pic>
         <p:nvPicPr>
-          <p:cNvPr id="9" name="Picture 8" descr="21_hopping-static_webp.jpg"/>
+          <p:cNvPr id="9" name="Picture 8" descr="21_hopping_jpg.jpg"/>
           <p:cNvPicPr>
             <a:picLocks noChangeAspect="1"/>
           </p:cNvPicPr>
@@ -30454,8 +30454,8 @@
         </p:blipFill>
         <p:spPr>
           <a:xfrm>
-            <a:off x="676656" y="2074951"/>
-            <a:ext cx="5769864" cy="3814521"/>
+            <a:off x="1889163" y="2048256"/>
+            <a:ext cx="3344849" cy="3867911"/>
           </a:xfrm>
           <a:prstGeom prst="rect">
             <a:avLst/>
@@ -31021,8 +31021,8 @@
         </p:nvSpPr>
         <p:spPr>
           <a:xfrm>
-            <a:off x="566928" y="1920240"/>
-            <a:ext cx="5989320" cy="4123944"/>
+            <a:off x="1798242" y="1920240"/>
+            <a:ext cx="3526692" cy="4123944"/>
           </a:xfrm>
           <a:prstGeom prst="roundRect">
             <a:avLst>
@@ -31061,7 +31061,7 @@
       </p:sp>
       <p:pic>
         <p:nvPicPr>
-          <p:cNvPr id="9" name="Picture 8" descr="22_side_toe_taps-static_webp.jpg"/>
+          <p:cNvPr id="9" name="Picture 8" descr="22_side_toe_taps_jpg.jpg"/>
           <p:cNvPicPr>
             <a:picLocks noChangeAspect="1"/>
           </p:cNvPicPr>
@@ -31075,8 +31075,8 @@
         </p:blipFill>
         <p:spPr>
           <a:xfrm>
-            <a:off x="676656" y="2074951"/>
-            <a:ext cx="5769864" cy="3814521"/>
+            <a:off x="1926258" y="2048257"/>
+            <a:ext cx="3270660" cy="3867910"/>
           </a:xfrm>
           <a:prstGeom prst="rect">
             <a:avLst/>
@@ -31642,8 +31642,8 @@
         </p:nvSpPr>
         <p:spPr>
           <a:xfrm>
-            <a:off x="566928" y="1920240"/>
-            <a:ext cx="5989320" cy="4123944"/>
+            <a:off x="1984813" y="1920240"/>
+            <a:ext cx="3153549" cy="4123944"/>
           </a:xfrm>
           <a:prstGeom prst="roundRect">
             <a:avLst>
@@ -31682,7 +31682,7 @@
       </p:sp>
       <p:pic>
         <p:nvPicPr>
-          <p:cNvPr id="9" name="Picture 8" descr="23_side_hops-static_webp.jpg"/>
+          <p:cNvPr id="9" name="Picture 8" descr="23_side_hops_jpg.jpg"/>
           <p:cNvPicPr>
             <a:picLocks noChangeAspect="1"/>
           </p:cNvPicPr>
@@ -31696,8 +31696,8 @@
         </p:blipFill>
         <p:spPr>
           <a:xfrm>
-            <a:off x="676656" y="2074951"/>
-            <a:ext cx="5769864" cy="3814521"/>
+            <a:off x="2112829" y="2048256"/>
+            <a:ext cx="2897517" cy="3867911"/>
           </a:xfrm>
           <a:prstGeom prst="rect">
             <a:avLst/>

</xml_diff>

<commit_message>
Presentations: keep the cartilhas' own exercise photos (#4)
The decks were built with the new design-system illustrations, which are not in
the cartilhas yet - so the patient would see one thing on the shared screen and
another when she opened the app afterwards. Both decks now use the photographs
that are actually in the cartilhas.

The exercise card also follows the picture's proportions now: the photos are
portrait and the fixed box left a wide white band beside them.

USAR_ILUSTRACOES_NOVAS stays in both generators, switched off, for the day the
new illustrations do land in the cartilhas.

Co-authored-by: Claude Opus 4.8 <noreply@anthropic.com>
</commit_message>
<xml_diff>
--- a/design/apresentacoes/Cartilha-Halux-Valgo-Apresentacao.pptx
+++ b/design/apresentacoes/Cartilha-Halux-Valgo-Apresentacao.pptx
@@ -14029,8 +14029,8 @@
         </p:nvSpPr>
         <p:spPr>
           <a:xfrm>
-            <a:off x="566928" y="1920240"/>
-            <a:ext cx="5989320" cy="4123944"/>
+            <a:off x="566928" y="2181987"/>
+            <a:ext cx="5989320" cy="3600450"/>
           </a:xfrm>
           <a:prstGeom prst="roundRect">
             <a:avLst>
@@ -14069,7 +14069,7 @@
       </p:sp>
       <p:pic>
         <p:nvPicPr>
-          <p:cNvPr id="9" name="Picture 8" descr="01_ball_release-static_webp.jpg"/>
+          <p:cNvPr id="9" name="Picture 8" descr="01_ball_release_jpg.jpg"/>
           <p:cNvPicPr>
             <a:picLocks noChangeAspect="1"/>
           </p:cNvPicPr>
@@ -14083,8 +14083,8 @@
         </p:blipFill>
         <p:spPr>
           <a:xfrm>
-            <a:off x="676656" y="2074951"/>
-            <a:ext cx="5769864" cy="3814521"/>
+            <a:off x="694944" y="2310003"/>
+            <a:ext cx="5733288" cy="3344418"/>
           </a:xfrm>
           <a:prstGeom prst="rect">
             <a:avLst/>
@@ -14927,8 +14927,8 @@
         </p:nvSpPr>
         <p:spPr>
           <a:xfrm>
-            <a:off x="566928" y="1920240"/>
-            <a:ext cx="5989320" cy="4123944"/>
+            <a:off x="862048" y="1920240"/>
+            <a:ext cx="5399079" cy="4123944"/>
           </a:xfrm>
           <a:prstGeom prst="roundRect">
             <a:avLst>
@@ -14967,7 +14967,7 @@
       </p:sp>
       <p:pic>
         <p:nvPicPr>
-          <p:cNvPr id="9" name="Picture 8" descr="02_passive_movements-static_webp.jpg"/>
+          <p:cNvPr id="9" name="Picture 8" descr="02_passive_movements_jpg.jpg"/>
           <p:cNvPicPr>
             <a:picLocks noChangeAspect="1"/>
           </p:cNvPicPr>
@@ -14981,8 +14981,8 @@
         </p:blipFill>
         <p:spPr>
           <a:xfrm>
-            <a:off x="676656" y="2074951"/>
-            <a:ext cx="5769864" cy="3814521"/>
+            <a:off x="990064" y="2048256"/>
+            <a:ext cx="5143047" cy="3867911"/>
           </a:xfrm>
           <a:prstGeom prst="rect">
             <a:avLst/>
@@ -15548,8 +15548,8 @@
         </p:nvSpPr>
         <p:spPr>
           <a:xfrm>
-            <a:off x="566928" y="1920240"/>
-            <a:ext cx="5989320" cy="4123944"/>
+            <a:off x="566928" y="1996934"/>
+            <a:ext cx="5989320" cy="3970556"/>
           </a:xfrm>
           <a:prstGeom prst="roundRect">
             <a:avLst>
@@ -15588,7 +15588,7 @@
       </p:sp>
       <p:pic>
         <p:nvPicPr>
-          <p:cNvPr id="9" name="Picture 8" descr="03_joint_traction-static_webp.jpg"/>
+          <p:cNvPr id="9" name="Picture 8" descr="03_joint_traction_jpg.jpg"/>
           <p:cNvPicPr>
             <a:picLocks noChangeAspect="1"/>
           </p:cNvPicPr>
@@ -15602,8 +15602,8 @@
         </p:blipFill>
         <p:spPr>
           <a:xfrm>
-            <a:off x="676656" y="2074951"/>
-            <a:ext cx="5769864" cy="3814521"/>
+            <a:off x="694944" y="2124950"/>
+            <a:ext cx="5733287" cy="3714524"/>
           </a:xfrm>
           <a:prstGeom prst="rect">
             <a:avLst/>
@@ -16169,8 +16169,8 @@
         </p:nvSpPr>
         <p:spPr>
           <a:xfrm>
-            <a:off x="566928" y="1920240"/>
-            <a:ext cx="5989320" cy="4123944"/>
+            <a:off x="566928" y="2020505"/>
+            <a:ext cx="5989320" cy="3923414"/>
           </a:xfrm>
           <a:prstGeom prst="roundRect">
             <a:avLst>
@@ -16209,7 +16209,7 @@
       </p:sp>
       <p:pic>
         <p:nvPicPr>
-          <p:cNvPr id="9" name="Picture 8" descr="04_joint_mobilization-static_webp.jpg"/>
+          <p:cNvPr id="9" name="Picture 8" descr="04_joint_mobilization_jpg.jpg"/>
           <p:cNvPicPr>
             <a:picLocks noChangeAspect="1"/>
           </p:cNvPicPr>
@@ -16223,8 +16223,8 @@
         </p:blipFill>
         <p:spPr>
           <a:xfrm>
-            <a:off x="676656" y="2074951"/>
-            <a:ext cx="5769864" cy="3814521"/>
+            <a:off x="694944" y="2148521"/>
+            <a:ext cx="5733287" cy="3667382"/>
           </a:xfrm>
           <a:prstGeom prst="rect">
             <a:avLst/>
@@ -16790,8 +16790,8 @@
         </p:nvSpPr>
         <p:spPr>
           <a:xfrm>
-            <a:off x="566928" y="1920240"/>
-            <a:ext cx="5989320" cy="4123944"/>
+            <a:off x="566928" y="1977847"/>
+            <a:ext cx="5989320" cy="4008729"/>
           </a:xfrm>
           <a:prstGeom prst="roundRect">
             <a:avLst>
@@ -16830,7 +16830,7 @@
       </p:sp>
       <p:pic>
         <p:nvPicPr>
-          <p:cNvPr id="9" name="Picture 8" descr="05_extensor_release-static_webp.jpg"/>
+          <p:cNvPr id="9" name="Picture 8" descr="05_extensor_release_jpg.jpg"/>
           <p:cNvPicPr>
             <a:picLocks noChangeAspect="1"/>
           </p:cNvPicPr>
@@ -16844,8 +16844,8 @@
         </p:blipFill>
         <p:spPr>
           <a:xfrm>
-            <a:off x="676656" y="2074951"/>
-            <a:ext cx="5769864" cy="3814521"/>
+            <a:off x="694944" y="2105863"/>
+            <a:ext cx="5733287" cy="3752697"/>
           </a:xfrm>
           <a:prstGeom prst="rect">
             <a:avLst/>
@@ -17411,8 +17411,8 @@
         </p:nvSpPr>
         <p:spPr>
           <a:xfrm>
-            <a:off x="566928" y="1920240"/>
-            <a:ext cx="5989320" cy="4123944"/>
+            <a:off x="566928" y="1961889"/>
+            <a:ext cx="5989320" cy="4040646"/>
           </a:xfrm>
           <a:prstGeom prst="roundRect">
             <a:avLst>
@@ -17451,7 +17451,7 @@
       </p:sp>
       <p:pic>
         <p:nvPicPr>
-          <p:cNvPr id="9" name="Picture 8" descr="06_capsule_massage-static_webp.jpg"/>
+          <p:cNvPr id="9" name="Picture 8" descr="06_joint_line_capsule_massage_jpg.jpg"/>
           <p:cNvPicPr>
             <a:picLocks noChangeAspect="1"/>
           </p:cNvPicPr>
@@ -17465,8 +17465,8 @@
         </p:blipFill>
         <p:spPr>
           <a:xfrm>
-            <a:off x="676656" y="2074951"/>
-            <a:ext cx="5769864" cy="3814521"/>
+            <a:off x="694944" y="2089905"/>
+            <a:ext cx="5733287" cy="3784614"/>
           </a:xfrm>
           <a:prstGeom prst="rect">
             <a:avLst/>
@@ -18555,8 +18555,8 @@
         </p:nvSpPr>
         <p:spPr>
           <a:xfrm>
-            <a:off x="566928" y="1920240"/>
-            <a:ext cx="5989320" cy="4123944"/>
+            <a:off x="963245" y="1920240"/>
+            <a:ext cx="5196685" cy="4123944"/>
           </a:xfrm>
           <a:prstGeom prst="roundRect">
             <a:avLst>
@@ -18595,7 +18595,7 @@
       </p:sp>
       <p:pic>
         <p:nvPicPr>
-          <p:cNvPr id="9" name="Picture 8" descr="07_flexion_stretch-static_webp.jpg"/>
+          <p:cNvPr id="9" name="Picture 8" descr="07_big_toe_flexion_stretch_jpg.jpg"/>
           <p:cNvPicPr>
             <a:picLocks noChangeAspect="1"/>
           </p:cNvPicPr>
@@ -18609,8 +18609,8 @@
         </p:blipFill>
         <p:spPr>
           <a:xfrm>
-            <a:off x="676656" y="2074951"/>
-            <a:ext cx="5769864" cy="3814521"/>
+            <a:off x="1091261" y="2048256"/>
+            <a:ext cx="4940653" cy="3867911"/>
           </a:xfrm>
           <a:prstGeom prst="rect">
             <a:avLst/>
@@ -19176,8 +19176,8 @@
         </p:nvSpPr>
         <p:spPr>
           <a:xfrm>
-            <a:off x="566928" y="1920240"/>
-            <a:ext cx="5989320" cy="4123944"/>
+            <a:off x="1342809" y="1920240"/>
+            <a:ext cx="4437558" cy="4123944"/>
           </a:xfrm>
           <a:prstGeom prst="roundRect">
             <a:avLst>
@@ -19216,7 +19216,7 @@
       </p:sp>
       <p:pic>
         <p:nvPicPr>
-          <p:cNvPr id="9" name="Picture 8" descr="08_extension_stretch-static_webp.jpg"/>
+          <p:cNvPr id="9" name="Picture 8" descr="08_big_toe_extension_stretch_jpg.jpg"/>
           <p:cNvPicPr>
             <a:picLocks noChangeAspect="1"/>
           </p:cNvPicPr>
@@ -19230,8 +19230,8 @@
         </p:blipFill>
         <p:spPr>
           <a:xfrm>
-            <a:off x="676656" y="2074951"/>
-            <a:ext cx="5769864" cy="3814521"/>
+            <a:off x="1470825" y="2048256"/>
+            <a:ext cx="4181526" cy="3867911"/>
           </a:xfrm>
           <a:prstGeom prst="rect">
             <a:avLst/>
@@ -19797,8 +19797,8 @@
         </p:nvSpPr>
         <p:spPr>
           <a:xfrm>
-            <a:off x="566928" y="1920240"/>
-            <a:ext cx="5989320" cy="4123944"/>
+            <a:off x="1001085" y="1920240"/>
+            <a:ext cx="5121005" cy="4123944"/>
           </a:xfrm>
           <a:prstGeom prst="roundRect">
             <a:avLst>
@@ -19837,7 +19837,7 @@
       </p:sp>
       <p:pic>
         <p:nvPicPr>
-          <p:cNvPr id="9" name="Picture 8" descr="09_extension_wall-static_webp.jpg"/>
+          <p:cNvPr id="9" name="Picture 8" descr="09_big_toe_extension_against_wall_jpg.jpg"/>
           <p:cNvPicPr>
             <a:picLocks noChangeAspect="1"/>
           </p:cNvPicPr>
@@ -19851,8 +19851,8 @@
         </p:blipFill>
         <p:spPr>
           <a:xfrm>
-            <a:off x="676656" y="2074951"/>
-            <a:ext cx="5769864" cy="3814521"/>
+            <a:off x="1129101" y="2048256"/>
+            <a:ext cx="4864973" cy="3867911"/>
           </a:xfrm>
           <a:prstGeom prst="rect">
             <a:avLst/>
@@ -20418,8 +20418,8 @@
         </p:nvSpPr>
         <p:spPr>
           <a:xfrm>
-            <a:off x="566928" y="1920240"/>
-            <a:ext cx="5989320" cy="4123944"/>
+            <a:off x="860798" y="1920240"/>
+            <a:ext cx="5401580" cy="4123944"/>
           </a:xfrm>
           <a:prstGeom prst="roundRect">
             <a:avLst>
@@ -20458,7 +20458,7 @@
       </p:sp>
       <p:pic>
         <p:nvPicPr>
-          <p:cNvPr id="9" name="Picture 8" descr="10_advanced_extension-static_webp.jpg"/>
+          <p:cNvPr id="9" name="Picture 8" descr="10_advanced_extension_stretch_jpg.jpg"/>
           <p:cNvPicPr>
             <a:picLocks noChangeAspect="1"/>
           </p:cNvPicPr>
@@ -20472,8 +20472,8 @@
         </p:blipFill>
         <p:spPr>
           <a:xfrm>
-            <a:off x="676656" y="2074951"/>
-            <a:ext cx="5769864" cy="3814521"/>
+            <a:off x="988814" y="2048256"/>
+            <a:ext cx="5145548" cy="3867911"/>
           </a:xfrm>
           <a:prstGeom prst="rect">
             <a:avLst/>
@@ -21558,8 +21558,8 @@
         </p:nvSpPr>
         <p:spPr>
           <a:xfrm>
-            <a:off x="566928" y="1920240"/>
-            <a:ext cx="5989320" cy="4123944"/>
+            <a:off x="989052" y="1920240"/>
+            <a:ext cx="5145072" cy="4123944"/>
           </a:xfrm>
           <a:prstGeom prst="roundRect">
             <a:avLst>
@@ -21598,7 +21598,7 @@
       </p:sp>
       <p:pic>
         <p:nvPicPr>
-          <p:cNvPr id="9" name="Picture 8" descr="11_abduction_stretch-static_webp.jpg"/>
+          <p:cNvPr id="9" name="Picture 8" descr="11_big_toe_abduction_stretch_jpg.jpg"/>
           <p:cNvPicPr>
             <a:picLocks noChangeAspect="1"/>
           </p:cNvPicPr>
@@ -21612,8 +21612,8 @@
         </p:blipFill>
         <p:spPr>
           <a:xfrm>
-            <a:off x="676656" y="2074951"/>
-            <a:ext cx="5769864" cy="3814521"/>
+            <a:off x="1117068" y="2048256"/>
+            <a:ext cx="4889040" cy="3867911"/>
           </a:xfrm>
           <a:prstGeom prst="rect">
             <a:avLst/>
@@ -22674,8 +22674,8 @@
         </p:nvSpPr>
         <p:spPr>
           <a:xfrm>
-            <a:off x="566928" y="1920240"/>
-            <a:ext cx="5989320" cy="4123944"/>
+            <a:off x="2125514" y="1920240"/>
+            <a:ext cx="2872147" cy="4123944"/>
           </a:xfrm>
           <a:prstGeom prst="roundRect">
             <a:avLst>
@@ -22714,7 +22714,7 @@
       </p:sp>
       <p:pic>
         <p:nvPicPr>
-          <p:cNvPr id="9" name="Picture 8" descr="12_big_toe_lift-static_webp.jpg"/>
+          <p:cNvPr id="9" name="Picture 8" descr="12_big_toe_lift_jpg.jpg"/>
           <p:cNvPicPr>
             <a:picLocks noChangeAspect="1"/>
           </p:cNvPicPr>
@@ -22728,8 +22728,8 @@
         </p:blipFill>
         <p:spPr>
           <a:xfrm>
-            <a:off x="676656" y="2074951"/>
-            <a:ext cx="5769864" cy="3814521"/>
+            <a:off x="2253530" y="2048256"/>
+            <a:ext cx="2616115" cy="3867911"/>
           </a:xfrm>
           <a:prstGeom prst="rect">
             <a:avLst/>
@@ -23295,8 +23295,8 @@
         </p:nvSpPr>
         <p:spPr>
           <a:xfrm>
-            <a:off x="566928" y="1920240"/>
-            <a:ext cx="5989320" cy="4123944"/>
+            <a:off x="566928" y="2001478"/>
+            <a:ext cx="5989320" cy="3961468"/>
           </a:xfrm>
           <a:prstGeom prst="roundRect">
             <a:avLst>
@@ -23335,7 +23335,7 @@
       </p:sp>
       <p:pic>
         <p:nvPicPr>
-          <p:cNvPr id="9" name="Picture 8" descr="13_big_toe_press-static_webp.jpg"/>
+          <p:cNvPr id="9" name="Picture 8" descr="13_big_toe_press_down_jpg.jpg"/>
           <p:cNvPicPr>
             <a:picLocks noChangeAspect="1"/>
           </p:cNvPicPr>
@@ -23349,8 +23349,8 @@
         </p:blipFill>
         <p:spPr>
           <a:xfrm>
-            <a:off x="676656" y="2074951"/>
-            <a:ext cx="5769864" cy="3814521"/>
+            <a:off x="694945" y="2129494"/>
+            <a:ext cx="5733286" cy="3705436"/>
           </a:xfrm>
           <a:prstGeom prst="rect">
             <a:avLst/>
@@ -23916,8 +23916,8 @@
         </p:nvSpPr>
         <p:spPr>
           <a:xfrm>
-            <a:off x="566928" y="1920240"/>
-            <a:ext cx="5989320" cy="4123944"/>
+            <a:off x="1846939" y="1920240"/>
+            <a:ext cx="3429298" cy="4123944"/>
           </a:xfrm>
           <a:prstGeom prst="roundRect">
             <a:avLst>
@@ -23956,7 +23956,7 @@
       </p:sp>
       <p:pic>
         <p:nvPicPr>
-          <p:cNvPr id="9" name="Picture 8" descr="14_abduction_isometric-static_webp.jpg"/>
+          <p:cNvPr id="9" name="Picture 8" descr="14_abduction_isometric_jpg.jpg"/>
           <p:cNvPicPr>
             <a:picLocks noChangeAspect="1"/>
           </p:cNvPicPr>
@@ -23970,8 +23970,8 @@
         </p:blipFill>
         <p:spPr>
           <a:xfrm>
-            <a:off x="676656" y="2074951"/>
-            <a:ext cx="5769864" cy="3814521"/>
+            <a:off x="1974955" y="2048256"/>
+            <a:ext cx="3173266" cy="3867911"/>
           </a:xfrm>
           <a:prstGeom prst="rect">
             <a:avLst/>
@@ -24537,8 +24537,8 @@
         </p:nvSpPr>
         <p:spPr>
           <a:xfrm>
-            <a:off x="566928" y="1920240"/>
-            <a:ext cx="5989320" cy="4123944"/>
+            <a:off x="2150527" y="1920240"/>
+            <a:ext cx="2822122" cy="4123944"/>
           </a:xfrm>
           <a:prstGeom prst="roundRect">
             <a:avLst>
@@ -24577,7 +24577,7 @@
       </p:sp>
       <p:pic>
         <p:nvPicPr>
-          <p:cNvPr id="9" name="Picture 8" descr="15_spread_squeeze-static_webp.jpg"/>
+          <p:cNvPr id="9" name="Picture 8" descr="15_spread_squeeze_jpg.jpg"/>
           <p:cNvPicPr>
             <a:picLocks noChangeAspect="1"/>
           </p:cNvPicPr>
@@ -24591,8 +24591,8 @@
         </p:blipFill>
         <p:spPr>
           <a:xfrm>
-            <a:off x="676656" y="2074951"/>
-            <a:ext cx="5769864" cy="3814521"/>
+            <a:off x="2278543" y="2048256"/>
+            <a:ext cx="2566090" cy="3867911"/>
           </a:xfrm>
           <a:prstGeom prst="rect">
             <a:avLst/>
@@ -25625,8 +25625,8 @@
         </p:nvSpPr>
         <p:spPr>
           <a:xfrm>
-            <a:off x="566928" y="1920240"/>
-            <a:ext cx="5989320" cy="4123944"/>
+            <a:off x="2449282" y="1920240"/>
+            <a:ext cx="2224611" cy="4123944"/>
           </a:xfrm>
           <a:prstGeom prst="roundRect">
             <a:avLst>
@@ -25665,7 +25665,7 @@
       </p:sp>
       <p:pic>
         <p:nvPicPr>
-          <p:cNvPr id="9" name="Picture 8" descr="16_forward_lean-static_webp.jpg"/>
+          <p:cNvPr id="9" name="Picture 8" descr="16_forward_lean_jpg.jpg"/>
           <p:cNvPicPr>
             <a:picLocks noChangeAspect="1"/>
           </p:cNvPicPr>
@@ -25679,8 +25679,8 @@
         </p:blipFill>
         <p:spPr>
           <a:xfrm>
-            <a:off x="676656" y="2074951"/>
-            <a:ext cx="5769864" cy="3814521"/>
+            <a:off x="2577298" y="2048256"/>
+            <a:ext cx="1968579" cy="3867911"/>
           </a:xfrm>
           <a:prstGeom prst="rect">
             <a:avLst/>
@@ -26246,8 +26246,8 @@
         </p:nvSpPr>
         <p:spPr>
           <a:xfrm>
-            <a:off x="566928" y="1920240"/>
-            <a:ext cx="5989320" cy="4123944"/>
+            <a:off x="2036826" y="1920240"/>
+            <a:ext cx="3049524" cy="4123944"/>
           </a:xfrm>
           <a:prstGeom prst="roundRect">
             <a:avLst>
@@ -26286,7 +26286,7 @@
       </p:sp>
       <p:pic>
         <p:nvPicPr>
-          <p:cNvPr id="9" name="Picture 8" descr="17_heel_raise-static_webp.jpg"/>
+          <p:cNvPr id="9" name="Picture 8" descr="17_heel_raise_jpg.jpg"/>
           <p:cNvPicPr>
             <a:picLocks noChangeAspect="1"/>
           </p:cNvPicPr>
@@ -26300,8 +26300,8 @@
         </p:blipFill>
         <p:spPr>
           <a:xfrm>
-            <a:off x="676656" y="2074951"/>
-            <a:ext cx="5769864" cy="3814521"/>
+            <a:off x="2164842" y="2048256"/>
+            <a:ext cx="2793492" cy="3867912"/>
           </a:xfrm>
           <a:prstGeom prst="rect">
             <a:avLst/>
@@ -26867,8 +26867,8 @@
         </p:nvSpPr>
         <p:spPr>
           <a:xfrm>
-            <a:off x="566928" y="1920240"/>
-            <a:ext cx="5989320" cy="4123944"/>
+            <a:off x="2044580" y="1920240"/>
+            <a:ext cx="3034016" cy="4123944"/>
           </a:xfrm>
           <a:prstGeom prst="roundRect">
             <a:avLst>
@@ -26907,7 +26907,7 @@
       </p:sp>
       <p:pic>
         <p:nvPicPr>
-          <p:cNvPr id="9" name="Picture 8" descr="18_push_off-static_webp.jpg"/>
+          <p:cNvPr id="9" name="Picture 8" descr="18_push_off_with_trailing_leg_jpg.jpg"/>
           <p:cNvPicPr>
             <a:picLocks noChangeAspect="1"/>
           </p:cNvPicPr>
@@ -26921,8 +26921,8 @@
         </p:blipFill>
         <p:spPr>
           <a:xfrm>
-            <a:off x="676656" y="2074951"/>
-            <a:ext cx="5769864" cy="3814521"/>
+            <a:off x="2172596" y="2048257"/>
+            <a:ext cx="2777984" cy="3867910"/>
           </a:xfrm>
           <a:prstGeom prst="rect">
             <a:avLst/>
@@ -29158,8 +29158,8 @@
         </p:nvSpPr>
         <p:spPr>
           <a:xfrm>
-            <a:off x="566928" y="1920240"/>
-            <a:ext cx="5989320" cy="4123944"/>
+            <a:off x="1704305" y="1920240"/>
+            <a:ext cx="3714566" cy="4123944"/>
           </a:xfrm>
           <a:prstGeom prst="roundRect">
             <a:avLst>
@@ -29198,7 +29198,7 @@
       </p:sp>
       <p:pic>
         <p:nvPicPr>
-          <p:cNvPr id="9" name="Picture 8" descr="19_lunges-static_webp.jpg"/>
+          <p:cNvPr id="9" name="Picture 8" descr="19_lunges_jpg.jpg"/>
           <p:cNvPicPr>
             <a:picLocks noChangeAspect="1"/>
           </p:cNvPicPr>
@@ -29212,8 +29212,8 @@
         </p:blipFill>
         <p:spPr>
           <a:xfrm>
-            <a:off x="676656" y="2074951"/>
-            <a:ext cx="5769864" cy="3814521"/>
+            <a:off x="1832321" y="2048256"/>
+            <a:ext cx="3458534" cy="3867911"/>
           </a:xfrm>
           <a:prstGeom prst="rect">
             <a:avLst/>
@@ -29779,8 +29779,8 @@
         </p:nvSpPr>
         <p:spPr>
           <a:xfrm>
-            <a:off x="566928" y="1920240"/>
-            <a:ext cx="5989320" cy="4123944"/>
+            <a:off x="566928" y="2258431"/>
+            <a:ext cx="5989320" cy="3447562"/>
           </a:xfrm>
           <a:prstGeom prst="roundRect">
             <a:avLst>
@@ -29819,7 +29819,7 @@
       </p:sp>
       <p:pic>
         <p:nvPicPr>
-          <p:cNvPr id="9" name="Picture 8" descr="20_mountain_climbers-static_webp.jpg"/>
+          <p:cNvPr id="9" name="Picture 8" descr="20_mountain_climbers_jpg.jpg"/>
           <p:cNvPicPr>
             <a:picLocks noChangeAspect="1"/>
           </p:cNvPicPr>
@@ -29833,8 +29833,8 @@
         </p:blipFill>
         <p:spPr>
           <a:xfrm>
-            <a:off x="676656" y="2074951"/>
-            <a:ext cx="5769864" cy="3814521"/>
+            <a:off x="694944" y="2386447"/>
+            <a:ext cx="5733287" cy="3191530"/>
           </a:xfrm>
           <a:prstGeom prst="rect">
             <a:avLst/>
@@ -30400,8 +30400,8 @@
         </p:nvSpPr>
         <p:spPr>
           <a:xfrm>
-            <a:off x="566928" y="1920240"/>
-            <a:ext cx="5989320" cy="4123944"/>
+            <a:off x="1761147" y="1920240"/>
+            <a:ext cx="3600881" cy="4123944"/>
           </a:xfrm>
           <a:prstGeom prst="roundRect">
             <a:avLst>
@@ -30440,7 +30440,7 @@
       </p:sp>
       <p:pic>
         <p:nvPicPr>
-          <p:cNvPr id="9" name="Picture 8" descr="21_hopping-static_webp.jpg"/>
+          <p:cNvPr id="9" name="Picture 8" descr="21_hopping_jpg.jpg"/>
           <p:cNvPicPr>
             <a:picLocks noChangeAspect="1"/>
           </p:cNvPicPr>
@@ -30454,8 +30454,8 @@
         </p:blipFill>
         <p:spPr>
           <a:xfrm>
-            <a:off x="676656" y="2074951"/>
-            <a:ext cx="5769864" cy="3814521"/>
+            <a:off x="1889163" y="2048256"/>
+            <a:ext cx="3344849" cy="3867911"/>
           </a:xfrm>
           <a:prstGeom prst="rect">
             <a:avLst/>
@@ -31021,8 +31021,8 @@
         </p:nvSpPr>
         <p:spPr>
           <a:xfrm>
-            <a:off x="566928" y="1920240"/>
-            <a:ext cx="5989320" cy="4123944"/>
+            <a:off x="1798242" y="1920240"/>
+            <a:ext cx="3526692" cy="4123944"/>
           </a:xfrm>
           <a:prstGeom prst="roundRect">
             <a:avLst>
@@ -31061,7 +31061,7 @@
       </p:sp>
       <p:pic>
         <p:nvPicPr>
-          <p:cNvPr id="9" name="Picture 8" descr="22_side_toe_taps-static_webp.jpg"/>
+          <p:cNvPr id="9" name="Picture 8" descr="22_side_toe_taps_jpg.jpg"/>
           <p:cNvPicPr>
             <a:picLocks noChangeAspect="1"/>
           </p:cNvPicPr>
@@ -31075,8 +31075,8 @@
         </p:blipFill>
         <p:spPr>
           <a:xfrm>
-            <a:off x="676656" y="2074951"/>
-            <a:ext cx="5769864" cy="3814521"/>
+            <a:off x="1926258" y="2048257"/>
+            <a:ext cx="3270660" cy="3867910"/>
           </a:xfrm>
           <a:prstGeom prst="rect">
             <a:avLst/>
@@ -31642,8 +31642,8 @@
         </p:nvSpPr>
         <p:spPr>
           <a:xfrm>
-            <a:off x="566928" y="1920240"/>
-            <a:ext cx="5989320" cy="4123944"/>
+            <a:off x="1984813" y="1920240"/>
+            <a:ext cx="3153549" cy="4123944"/>
           </a:xfrm>
           <a:prstGeom prst="roundRect">
             <a:avLst>
@@ -31682,7 +31682,7 @@
       </p:sp>
       <p:pic>
         <p:nvPicPr>
-          <p:cNvPr id="9" name="Picture 8" descr="23_side_hops-static_webp.jpg"/>
+          <p:cNvPr id="9" name="Picture 8" descr="23_side_hops_jpg.jpg"/>
           <p:cNvPicPr>
             <a:picLocks noChangeAspect="1"/>
           </p:cNvPicPr>
@@ -31696,8 +31696,8 @@
         </p:blipFill>
         <p:spPr>
           <a:xfrm>
-            <a:off x="676656" y="2074951"/>
-            <a:ext cx="5769864" cy="3814521"/>
+            <a:off x="2112829" y="2048256"/>
+            <a:ext cx="2897517" cy="3867911"/>
           </a:xfrm>
           <a:prstGeom prst="rect">
             <a:avLst/>

</xml_diff>